<commit_message>
Finalizando Mobile e Web: Ajustes em Cadastro, Chat e Perfil
</commit_message>
<xml_diff>
--- a/Documentação/CIRCULARIS.pptx
+++ b/Documentação/CIRCULARIS.pptx
@@ -270,7 +270,7 @@
           <a:p>
             <a:fld id="{35A1A502-CEE6-4B19-BA0F-93C723E02574}" type="datetimeFigureOut">
               <a:rPr lang="pt-BR" smtClean="0"/>
-              <a:t>09/12/2025</a:t>
+              <a:t>10/12/2025</a:t>
             </a:fld>
             <a:endParaRPr lang="pt-BR"/>
           </a:p>
@@ -468,7 +468,7 @@
           <a:p>
             <a:fld id="{35A1A502-CEE6-4B19-BA0F-93C723E02574}" type="datetimeFigureOut">
               <a:rPr lang="pt-BR" smtClean="0"/>
-              <a:t>09/12/2025</a:t>
+              <a:t>10/12/2025</a:t>
             </a:fld>
             <a:endParaRPr lang="pt-BR"/>
           </a:p>
@@ -676,7 +676,7 @@
           <a:p>
             <a:fld id="{35A1A502-CEE6-4B19-BA0F-93C723E02574}" type="datetimeFigureOut">
               <a:rPr lang="pt-BR" smtClean="0"/>
-              <a:t>09/12/2025</a:t>
+              <a:t>10/12/2025</a:t>
             </a:fld>
             <a:endParaRPr lang="pt-BR"/>
           </a:p>
@@ -874,7 +874,7 @@
           <a:p>
             <a:fld id="{35A1A502-CEE6-4B19-BA0F-93C723E02574}" type="datetimeFigureOut">
               <a:rPr lang="pt-BR" smtClean="0"/>
-              <a:t>09/12/2025</a:t>
+              <a:t>10/12/2025</a:t>
             </a:fld>
             <a:endParaRPr lang="pt-BR"/>
           </a:p>
@@ -1149,7 +1149,7 @@
           <a:p>
             <a:fld id="{35A1A502-CEE6-4B19-BA0F-93C723E02574}" type="datetimeFigureOut">
               <a:rPr lang="pt-BR" smtClean="0"/>
-              <a:t>09/12/2025</a:t>
+              <a:t>10/12/2025</a:t>
             </a:fld>
             <a:endParaRPr lang="pt-BR"/>
           </a:p>
@@ -1414,7 +1414,7 @@
           <a:p>
             <a:fld id="{35A1A502-CEE6-4B19-BA0F-93C723E02574}" type="datetimeFigureOut">
               <a:rPr lang="pt-BR" smtClean="0"/>
-              <a:t>09/12/2025</a:t>
+              <a:t>10/12/2025</a:t>
             </a:fld>
             <a:endParaRPr lang="pt-BR"/>
           </a:p>
@@ -1826,7 +1826,7 @@
           <a:p>
             <a:fld id="{35A1A502-CEE6-4B19-BA0F-93C723E02574}" type="datetimeFigureOut">
               <a:rPr lang="pt-BR" smtClean="0"/>
-              <a:t>09/12/2025</a:t>
+              <a:t>10/12/2025</a:t>
             </a:fld>
             <a:endParaRPr lang="pt-BR"/>
           </a:p>
@@ -1967,7 +1967,7 @@
           <a:p>
             <a:fld id="{35A1A502-CEE6-4B19-BA0F-93C723E02574}" type="datetimeFigureOut">
               <a:rPr lang="pt-BR" smtClean="0"/>
-              <a:t>09/12/2025</a:t>
+              <a:t>10/12/2025</a:t>
             </a:fld>
             <a:endParaRPr lang="pt-BR"/>
           </a:p>
@@ -2080,7 +2080,7 @@
           <a:p>
             <a:fld id="{35A1A502-CEE6-4B19-BA0F-93C723E02574}" type="datetimeFigureOut">
               <a:rPr lang="pt-BR" smtClean="0"/>
-              <a:t>09/12/2025</a:t>
+              <a:t>10/12/2025</a:t>
             </a:fld>
             <a:endParaRPr lang="pt-BR"/>
           </a:p>
@@ -2391,7 +2391,7 @@
           <a:p>
             <a:fld id="{35A1A502-CEE6-4B19-BA0F-93C723E02574}" type="datetimeFigureOut">
               <a:rPr lang="pt-BR" smtClean="0"/>
-              <a:t>09/12/2025</a:t>
+              <a:t>10/12/2025</a:t>
             </a:fld>
             <a:endParaRPr lang="pt-BR"/>
           </a:p>
@@ -2679,7 +2679,7 @@
           <a:p>
             <a:fld id="{35A1A502-CEE6-4B19-BA0F-93C723E02574}" type="datetimeFigureOut">
               <a:rPr lang="pt-BR" smtClean="0"/>
-              <a:t>09/12/2025</a:t>
+              <a:t>10/12/2025</a:t>
             </a:fld>
             <a:endParaRPr lang="pt-BR"/>
           </a:p>
@@ -2920,7 +2920,7 @@
           <a:p>
             <a:fld id="{35A1A502-CEE6-4B19-BA0F-93C723E02574}" type="datetimeFigureOut">
               <a:rPr lang="pt-BR" smtClean="0"/>
-              <a:t>09/12/2025</a:t>
+              <a:t>10/12/2025</a:t>
             </a:fld>
             <a:endParaRPr lang="pt-BR"/>
           </a:p>
@@ -3405,10 +3405,7 @@
           <a:lstStyle/>
           <a:p>
             <a:pPr algn="ctr"/>
-            <a:r>
-              <a:rPr lang="pt-BR" dirty="0"/>
-              <a:t>-</a:t>
-            </a:r>
+            <a:endParaRPr lang="pt-BR" dirty="0"/>
           </a:p>
         </p:txBody>
       </p:sp>
@@ -11676,7 +11673,7 @@
                 <a:ea typeface="Verdana" panose="020B0604030504040204" pitchFamily="34" charset="0"/>
                 <a:cs typeface="Arial" panose="020B0604020202020204" pitchFamily="34" charset="0"/>
               </a:rPr>
-              <a:t>Aplicadas</a:t>
+              <a:t>Aplicados</a:t>
             </a:r>
             <a:endParaRPr lang="en-US" sz="3600" b="1" spc="200" dirty="0">
               <a:solidFill>

</xml_diff>